<commit_message>
Dữ liệu pin sạch: 2.089.048 dòng đo phục vụ phân tích và trích xuất đặc trưng
</commit_message>
<xml_diff>
--- a/docs/slide-bao-ve.pptx
+++ b/docs/slide-bao-ve.pptx
@@ -17,6 +17,7 @@
     <p:sldId id="265" r:id="rId16"/>
     <p:sldId id="266" r:id="rId17"/>
     <p:sldId id="267" r:id="rId18"/>
+    <p:sldId id="268" r:id="rId19"/>
   </p:sldIdLst>
   <p:sldSz cx="12191695" cy="6858000" type="screen4x3"/>
   <p:notesSz cx="6858000" cy="9144000"/>
@@ -3282,7 +3283,7 @@
               <a:defRPr sz="3200"/>
             </a:pPr>
             <a:r>
-              <a:t>Hạn chế</a:t>
+              <a:t>Phân tích bổ sung</a:t>
             </a:r>
           </a:p>
         </p:txBody>
@@ -3306,7 +3307,7 @@
               <a:defRPr sz="2300"/>
             </a:pPr>
             <a:r>
-              <a:t>Chỉ 3 pin, chưa kiểm định thống kê rộng</a:t>
+              <a:t>Bỏ nhóm đặc trưng: chênh lệch không đủ kết luận nhân quả</a:t>
             </a:r>
           </a:p>
           <a:p>
@@ -3314,7 +3315,7 @@
               <a:defRPr sz="2300"/>
             </a:pPr>
             <a:r>
-              <a:t>Chưa xác minh dữ liệu gốc, chuyển miền hoặc bộ pin xe</a:t>
+              <a:t>Kiểm thử 70/30 theo thời gian: RF kém baseline SOH cuối đã biết</a:t>
             </a:r>
           </a:p>
           <a:p>
@@ -3322,7 +3323,7 @@
               <a:defRPr sz="2300"/>
             </a:pPr>
             <a:r>
-              <a:t>Chưa có tuning, ablation và RUL</a:t>
+              <a:t>Không dùng kết quả này để tuyên bố dự đoán RUL</a:t>
             </a:r>
           </a:p>
         </p:txBody>
@@ -3364,6 +3365,88 @@
               <a:defRPr sz="3200"/>
             </a:pPr>
             <a:r>
+              <a:t>Hạn chế</a:t>
+            </a:r>
+          </a:p>
+        </p:txBody>
+      </p:sp>
+      <p:sp>
+        <p:nvSpPr>
+          <p:cNvPr id="3" name="Content Placeholder 2"/>
+          <p:cNvSpPr>
+            <a:spLocks noGrp="1"/>
+          </p:cNvSpPr>
+          <p:nvPr>
+            <p:ph idx="1"/>
+          </p:nvPr>
+        </p:nvSpPr>
+        <p:spPr/>
+        <p:txBody>
+          <a:bodyPr/>
+          <a:lstStyle/>
+          <a:p>
+            <a:pPr>
+              <a:defRPr sz="2300"/>
+            </a:pPr>
+            <a:r>
+              <a:t>2 triệu phép đo vẫn chỉ là 4 pin và 636 mẫu SOH</a:t>
+            </a:r>
+          </a:p>
+          <a:p>
+            <a:pPr>
+              <a:defRPr sz="2300"/>
+            </a:pPr>
+            <a:r>
+              <a:t>Chưa có dữ liệu Việt Nam hoặc xe vận hành thực tế</a:t>
+            </a:r>
+          </a:p>
+          <a:p>
+            <a:pPr>
+              <a:defRPr sz="2300"/>
+            </a:pPr>
+            <a:r>
+              <a:t>File MAT từ bản lưu, chưa đối chiếu byte với archive S3</a:t>
+            </a:r>
+          </a:p>
+        </p:txBody>
+      </p:sp>
+    </p:spTree>
+  </p:cSld>
+  <p:clrMapOvr>
+    <a:masterClrMapping/>
+  </p:clrMapOvr>
+</p:sld>
+</file>
+
+<file path=ppt/slides/slide13.xml><?xml version="1.0" encoding="utf-8"?>
+<p:sld xmlns:a="http://schemas.openxmlformats.org/drawingml/2006/main" xmlns:p="http://schemas.openxmlformats.org/presentationml/2006/main" xmlns:r="http://schemas.openxmlformats.org/officeDocument/2006/relationships">
+  <p:cSld>
+    <p:spTree>
+      <p:nvGrpSpPr>
+        <p:cNvPr id="1" name=""/>
+        <p:cNvGrpSpPr/>
+        <p:nvPr/>
+      </p:nvGrpSpPr>
+      <p:grpSpPr/>
+      <p:sp>
+        <p:nvSpPr>
+          <p:cNvPr id="2" name="Title 1"/>
+          <p:cNvSpPr>
+            <a:spLocks noGrp="1"/>
+          </p:cNvSpPr>
+          <p:nvPr>
+            <p:ph type="title"/>
+          </p:nvPr>
+        </p:nvSpPr>
+        <p:spPr/>
+        <p:txBody>
+          <a:bodyPr/>
+          <a:lstStyle/>
+          <a:p>
+            <a:pPr>
+              <a:defRPr sz="3200"/>
+            </a:pPr>
+            <a:r>
               <a:t>Kết luận và bước tiếp theo</a:t>
             </a:r>
           </a:p>
@@ -3388,7 +3471,7 @@
               <a:defRPr sz="2300"/>
             </a:pPr>
             <a:r>
-              <a:t>Pipeline, kiểm thử, demo và kết quả có thể tái lập</a:t>
+              <a:t>Pipeline, dữ liệu sạch, kiểm thử, demo và tài liệu tái lập</a:t>
             </a:r>
           </a:p>
           <a:p>
@@ -3396,7 +3479,7 @@
               <a:defRPr sz="2300"/>
             </a:pPr>
             <a:r>
-              <a:t>Xác minh MAT gốc và chạy lại</a:t>
+              <a:t>Bổ sung pin và điều kiện vận hành; đối chiếu kho phát hành</a:t>
             </a:r>
           </a:p>
           <a:p>
@@ -3404,7 +3487,7 @@
               <a:defRPr sz="2300"/>
             </a:pPr>
             <a:r>
-              <a:t>Thêm pin, điều kiện vận hành và tổng quan nghiên cứu</a:t>
+              <a:t>Giảng viên xác nhận phạm vi và hình thức bản nộp</a:t>
             </a:r>
           </a:p>
         </p:txBody>
@@ -3552,7 +3635,7 @@
               <a:defRPr sz="2300"/>
             </a:pPr>
             <a:r>
-              <a:t>Bản CSV cộng đồng dẫn nguồn NASA; ghim commit và SHA-256</a:t>
+              <a:t>Đọc MATLAB từ bản lưu công khai dẫn nguồn NASA</a:t>
             </a:r>
           </a:p>
           <a:p>
@@ -3560,7 +3643,7 @@
               <a:defRPr sz="2300"/>
             </a:pPr>
             <a:r>
-              <a:t>B05/B07/B18 · 468 chu kỳ</a:t>
+              <a:t>2.089.048 dòng sạch; 4 pin; 636 chu kỳ xả</a:t>
             </a:r>
           </a:p>
           <a:p>
@@ -3568,7 +3651,7 @@
               <a:defRPr sz="2300"/>
             </a:pPr>
             <a:r>
-              <a:t>Chưa đối chiếu MAT gốc; cần xác minh trục thời gian giống nhau</a:t>
+              <a:t>2 dòng sạc thiếu tín hiệu được loại có nhật ký; không nhân bản</a:t>
             </a:r>
           </a:p>
         </p:txBody>
@@ -3716,7 +3799,7 @@
               <a:defRPr sz="2300"/>
             </a:pPr>
             <a:r>
-              <a:t>Leave-one-battery-out: 3 vòng</a:t>
+              <a:t>Leave-one-battery-out: 4 vòng</a:t>
             </a:r>
           </a:p>
           <a:p>
@@ -3724,7 +3807,7 @@
               <a:defRPr sz="2300"/>
             </a:pPr>
             <a:r>
-              <a:t>Huấn luyện hai pin, kiểm thử pin còn lại</a:t>
+              <a:t>Huấn luyện ba pin, kiểm thử pin còn lại</a:t>
             </a:r>
           </a:p>
           <a:p>
@@ -3880,7 +3963,7 @@
               <a:defRPr sz="2300"/>
             </a:pPr>
             <a:r>
-              <a:t>RF macro MAE: 1.241 điểm phần trăm SOH</a:t>
+              <a:t>RF macro MAE: 2.724 điểm phần trăm SOH</a:t>
             </a:r>
           </a:p>
           <a:p>
@@ -3888,7 +3971,7 @@
               <a:defRPr sz="2300"/>
             </a:pPr>
             <a:r>
-              <a:t>RF macro RMSE: 1.628</a:t>
+              <a:t>RF macro RMSE: 3.189</a:t>
             </a:r>
           </a:p>
           <a:p>
@@ -4059,8 +4142,8 @@
         </p:blipFill>
         <p:spPr>
           <a:xfrm>
-            <a:off x="548640" y="1463040"/>
-            <a:ext cx="10972800" cy="2926080"/>
+            <a:off x="2560320" y="1463040"/>
+            <a:ext cx="7406640" cy="4937760"/>
           </a:xfrm>
           <a:prstGeom prst="rect">
             <a:avLst/>

</xml_diff>

<commit_message>
Giao diện tiếng Việt phục vụ tra cứu dữ liệu pin và so sánh kết quả mô hình
</commit_message>
<xml_diff>
--- a/docs/slide-bao-ve.pptx
+++ b/docs/slide-bao-ve.pptx
@@ -3225,7 +3225,7 @@
               <a:defRPr sz="2300"/>
             </a:pPr>
             <a:r>
-              <a:t>Tab dữ liệu và kết quả kiểm thử</a:t>
+              <a:t>PinLab: tổng quan, tra cứu, đánh giá, dự đoán, hồ sơ</a:t>
             </a:r>
           </a:p>
           <a:p>
@@ -3233,7 +3233,7 @@
               <a:defRPr sz="2300"/>
             </a:pPr>
             <a:r>
-              <a:t>Nhận CSV một chu kỳ; kiểm tra đơn vị và cửa sổ</a:t>
+              <a:t>CSV một chu kỳ; tên cột gốc hoặc tiếng Việt</a:t>
             </a:r>
           </a:p>
           <a:p>

</xml_diff>

<commit_message>
Vincent D: dự đoán SOH từng chu kỳ hoặc theo lô, tra cứu lịch sử và xuất báo cáo kết quả
</commit_message>
<xml_diff>
--- a/docs/slide-bao-ve.pptx
+++ b/docs/slide-bao-ve.pptx
@@ -3225,7 +3225,7 @@
               <a:defRPr sz="2300"/>
             </a:pPr>
             <a:r>
-              <a:t>PinLab: tổng quan, tra cứu, đánh giá, dự đoán, hồ sơ</a:t>
+              <a:t>Vincent D · Arial · 6 mục chức năng</a:t>
             </a:r>
           </a:p>
           <a:p>
@@ -3233,7 +3233,7 @@
               <a:defRPr sz="2300"/>
             </a:pPr>
             <a:r>
-              <a:t>CSV một chu kỳ; tên cột gốc hoặc tiếng Việt</a:t>
+              <a:t>Dự đoán đơn/lô, lịch sử và phiếu kết quả HTML</a:t>
             </a:r>
           </a:p>
           <a:p>

</xml_diff>

<commit_message>
Tra cứu dữ liệu SDU và dự đoán SOH từ CSV dung lượng lớn
10.505.065 dòng theo quy tắc lấy mỗi ba điểm, giữ đủ chu kỳ và cửa sổ mô hình. CSV/GZ tới 512 MiB, tên cột gốc SDU, 2.000 chu kỳ mỗi lô. Tiêu đề đề tài đầy đủ, Arial và nội dung giao diện gọn hơn. 47 kiểm thử đạt; file lớn nhất dự đoán đủ 1.321 chu kỳ.
</commit_message>
<xml_diff>
--- a/docs/slide-bao-ve.pptx
+++ b/docs/slide-bao-ve.pptx
@@ -6680,7 +6680,7 @@
               </a:defRPr>
             </a:pPr>
             <a:r>
-              <a:t>• Bản chọn: 10.000.000 dòng, đủ 20.823 chu kỳ</a:t>
+              <a:t>• Bản chọn: 10.505.065 dòng, đủ 20.823 chu kỳ</a:t>
             </a:r>
           </a:p>
           <a:p>
@@ -7241,7 +7241,7 @@
               </a:defRPr>
             </a:pPr>
             <a:r>
-              <a:t>• 25 điểm nghi vấn được giữ; không nằm trong 120 giây đầu</a:t>
+              <a:t>• 26 điểm nghi vấn được giữ; không nằm trong 120 giây đầu</a:t>
             </a:r>
           </a:p>
         </p:txBody>

</xml_diff>

<commit_message>
Vincent D: CSV/GZ dung lượng lớn, tiêu đề khóa luận và dữ liệu SDU lấy thưa theo quy tắc
</commit_message>
<xml_diff>
--- a/docs/slide-bao-ve.pptx
+++ b/docs/slide-bao-ve.pptx
@@ -6680,7 +6680,7 @@
               </a:defRPr>
             </a:pPr>
             <a:r>
-              <a:t>• Bản chọn: 10.000.000 dòng, đủ 20.823 chu kỳ</a:t>
+              <a:t>• Bản chọn: 10.505.065 dòng, đủ 20.823 chu kỳ</a:t>
             </a:r>
           </a:p>
           <a:p>
@@ -7241,7 +7241,7 @@
               </a:defRPr>
             </a:pPr>
             <a:r>
-              <a:t>• 25 điểm nghi vấn được giữ; không nằm trong 120 giây đầu</a:t>
+              <a:t>• 26 điểm nghi vấn được giữ; không nằm trong 120 giây đầu</a:t>
             </a:r>
           </a:p>
         </p:txBody>

</xml_diff>

<commit_message>
Ước lượng SOH bằng Ridge–RF phần dư và giám sát xu hướng pin
Phương án kết hợp dùng cùng nhóm pin, so sánh cặp theo pin; không tuyên bố thuật toán mới. Isolation Forest và nền quá khứ đánh dấu chu kỳ cần xem xét, chưa có nhãn lỗi hoặc kiểm chứng BMS. 58 kiểm thử đạt, báo cáo và notebook đồng bộ.
</commit_message>
<xml_diff>
--- a/docs/slide-bao-ve.pptx
+++ b/docs/slide-bao-ve.pptx
@@ -23,6 +23,8 @@
     <p:sldId id="271" r:id="rId22"/>
     <p:sldId id="272" r:id="rId23"/>
     <p:sldId id="273" r:id="rId24"/>
+    <p:sldId id="274" r:id="rId25"/>
+    <p:sldId id="275" r:id="rId26"/>
   </p:sldIdLst>
   <p:sldSz cx="12191695" cy="6858000" type="screen4x3"/>
   <p:notesSz cx="6858000" cy="9144000"/>
@@ -5441,7 +5443,7 @@
               </a:defRPr>
             </a:pPr>
             <a:r>
-              <a:t>Kết luận và hướng phát triển</a:t>
+              <a:t>Giám sát xu hướng SOH</a:t>
             </a:r>
           </a:p>
         </p:txBody>
@@ -5480,7 +5482,7 @@
               </a:defRPr>
             </a:pPr>
             <a:r>
-              <a:t>• Hoàn thành quy trình dữ liệu → mô hình → ứng dụng</a:t>
+              <a:t>• Quy tắc quá khứ và Isolation Forest · giữ riêng pin</a:t>
             </a:r>
           </a:p>
           <a:p>
@@ -5496,7 +5498,7 @@
               </a:defRPr>
             </a:pPr>
             <a:r>
-              <a:t>• Chưa kiểm chứng trên bộ pin xe thực tế tại Việt Nam</a:t>
+              <a:t>• 74 cờ giai đoạn đầu; 135 cờ tái sử dụng</a:t>
             </a:r>
           </a:p>
           <a:p>
@@ -5512,7 +5514,23 @@
               </a:defRPr>
             </a:pPr>
             <a:r>
-              <a:t>• Mở rộng điều kiện vận hành, đánh giá độc lập và độ bất định</a:t>
+              <a:t>• Chưa có nhãn lỗi; cờ không phải kết luận hỏng pin</a:t>
+            </a:r>
+          </a:p>
+          <a:p>
+            <a:pPr>
+              <a:spcAft>
+                <a:spcPts val="1600"/>
+              </a:spcAft>
+              <a:defRPr sz="2400" b="0">
+                <a:solidFill>
+                  <a:srgbClr val="193431"/>
+                </a:solidFill>
+                <a:latin typeface="Arial"/>
+              </a:defRPr>
+            </a:pPr>
+            <a:r>
+              <a:t>• Chưa có dữ liệu BMS để kiểm chứng trên xe</a:t>
             </a:r>
           </a:p>
         </p:txBody>
@@ -5737,7 +5755,7 @@
               </a:defRPr>
             </a:pPr>
             <a:r>
-              <a:t>Tài liệu và sản phẩm bàn giao</a:t>
+              <a:t>Ridge–RF hiệu chỉnh phần dư</a:t>
             </a:r>
           </a:p>
         </p:txBody>
@@ -5776,7 +5794,7 @@
               </a:defRPr>
             </a:pPr>
             <a:r>
-              <a:t>• Mã nguồn, mô hình, bảng đặc trưng và dữ liệu nguồn</a:t>
+              <a:t>• Ridge học nền; RF học sai số trên train</a:t>
             </a:r>
           </a:p>
           <a:p>
@@ -5792,7 +5810,7 @@
               </a:defRPr>
             </a:pPr>
             <a:r>
-              <a:t>• Notebook đã chạy, CSV thực nghiệm và biểu đồ</a:t>
+              <a:t>• Cùng 12 đặc trưng và 5 nhóm pin</a:t>
             </a:r>
           </a:p>
           <a:p>
@@ -5808,7 +5826,23 @@
               </a:defRPr>
             </a:pPr>
             <a:r>
-              <a:t>• Báo cáo Word/PDF, slide và hồ sơ trích dẫn</a:t>
+              <a:t>• MAE 1,612 so với RF 1,619; RMSE hơi tăng</a:t>
+            </a:r>
+          </a:p>
+          <a:p>
+            <a:pPr>
+              <a:spcAft>
+                <a:spcPts val="1600"/>
+              </a:spcAft>
+              <a:defRPr sz="2400" b="0">
+                <a:solidFill>
+                  <a:srgbClr val="193431"/>
+                </a:solidFill>
+                <a:latin typeface="Arial"/>
+              </a:defRPr>
+            </a:pPr>
+            <a:r>
+              <a:t>• Kết hợp có sẵn, chưa khẳng định thuật toán mới hay vượt trội</a:t>
             </a:r>
           </a:p>
         </p:txBody>
@@ -5887,6 +5921,302 @@
             </a:pPr>
             <a:r>
               <a:t>18</a:t>
+            </a:r>
+          </a:p>
+        </p:txBody>
+      </p:sp>
+    </p:spTree>
+  </p:cSld>
+  <p:clrMapOvr>
+    <a:masterClrMapping/>
+  </p:clrMapOvr>
+</p:sld>
+</file>
+
+<file path=ppt/slides/slide19.xml><?xml version="1.0" encoding="utf-8"?>
+<p:sld xmlns:a="http://schemas.openxmlformats.org/drawingml/2006/main" xmlns:p="http://schemas.openxmlformats.org/presentationml/2006/main" xmlns:r="http://schemas.openxmlformats.org/officeDocument/2006/relationships">
+  <p:cSld>
+    <p:bg>
+      <p:bgPr>
+        <a:solidFill>
+          <a:srgbClr val="F6F8F3"/>
+        </a:solidFill>
+        <a:effectLst/>
+      </p:bgPr>
+    </p:bg>
+    <p:spTree>
+      <p:nvGrpSpPr>
+        <p:cNvPr id="1" name=""/>
+        <p:cNvGrpSpPr/>
+        <p:nvPr/>
+      </p:nvGrpSpPr>
+      <p:grpSpPr/>
+      <p:sp>
+        <p:nvSpPr>
+          <p:cNvPr id="2" name="Rectangle 1"/>
+          <p:cNvSpPr/>
+          <p:nvPr/>
+        </p:nvSpPr>
+        <p:spPr>
+          <a:xfrm>
+            <a:off x="0" y="0"/>
+            <a:ext cx="146304" cy="6858000"/>
+          </a:xfrm>
+          <a:prstGeom prst="rect">
+            <a:avLst/>
+          </a:prstGeom>
+          <a:solidFill>
+            <a:srgbClr val="087F70"/>
+          </a:solidFill>
+          <a:ln>
+            <a:noFill/>
+          </a:ln>
+        </p:spPr>
+        <p:style>
+          <a:lnRef idx="1">
+            <a:schemeClr val="accent1"/>
+          </a:lnRef>
+          <a:fillRef idx="3">
+            <a:schemeClr val="accent1"/>
+          </a:fillRef>
+          <a:effectRef idx="2">
+            <a:schemeClr val="accent1"/>
+          </a:effectRef>
+          <a:fontRef idx="minor">
+            <a:schemeClr val="lt1"/>
+          </a:fontRef>
+        </p:style>
+        <p:txBody>
+          <a:bodyPr rtlCol="0" anchor="ctr"/>
+          <a:lstStyle/>
+          <a:p>
+            <a:pPr algn="ctr"/>
+          </a:p>
+        </p:txBody>
+      </p:sp>
+      <p:sp>
+        <p:nvSpPr>
+          <p:cNvPr id="3" name="TextBox 2"/>
+          <p:cNvSpPr txBox="1"/>
+          <p:nvPr/>
+        </p:nvSpPr>
+        <p:spPr>
+          <a:xfrm>
+            <a:off x="594360" y="274320"/>
+            <a:ext cx="10972800" cy="365760"/>
+          </a:xfrm>
+          <a:prstGeom prst="rect">
+            <a:avLst/>
+          </a:prstGeom>
+          <a:noFill/>
+        </p:spPr>
+        <p:txBody>
+          <a:bodyPr wrap="square">
+            <a:spAutoFit/>
+          </a:bodyPr>
+          <a:lstStyle/>
+          <a:p>
+            <a:pPr>
+              <a:spcAft>
+                <a:spcPts val="1600"/>
+              </a:spcAft>
+              <a:defRPr sz="1200" b="1">
+                <a:solidFill>
+                  <a:srgbClr val="087F70"/>
+                </a:solidFill>
+                <a:latin typeface="Arial"/>
+              </a:defRPr>
+            </a:pPr>
+            <a:r>
+              <a:t>VINCENT D / NGHIÊN CỨU SỨC KHỎE PIN</a:t>
+            </a:r>
+          </a:p>
+        </p:txBody>
+      </p:sp>
+      <p:sp>
+        <p:nvSpPr>
+          <p:cNvPr id="4" name="TextBox 3"/>
+          <p:cNvSpPr txBox="1"/>
+          <p:nvPr/>
+        </p:nvSpPr>
+        <p:spPr>
+          <a:xfrm>
+            <a:off x="594360" y="868680"/>
+            <a:ext cx="10972800" cy="1188720"/>
+          </a:xfrm>
+          <a:prstGeom prst="rect">
+            <a:avLst/>
+          </a:prstGeom>
+          <a:noFill/>
+        </p:spPr>
+        <p:txBody>
+          <a:bodyPr wrap="square">
+            <a:spAutoFit/>
+          </a:bodyPr>
+          <a:lstStyle/>
+          <a:p>
+            <a:pPr>
+              <a:spcAft>
+                <a:spcPts val="1600"/>
+              </a:spcAft>
+              <a:defRPr sz="3200" b="1">
+                <a:solidFill>
+                  <a:srgbClr val="193431"/>
+                </a:solidFill>
+                <a:latin typeface="Arial"/>
+              </a:defRPr>
+            </a:pPr>
+            <a:r>
+              <a:t>Kết luận và hướng phát triển</a:t>
+            </a:r>
+          </a:p>
+        </p:txBody>
+      </p:sp>
+      <p:sp>
+        <p:nvSpPr>
+          <p:cNvPr id="5" name="TextBox 4"/>
+          <p:cNvSpPr txBox="1"/>
+          <p:nvPr/>
+        </p:nvSpPr>
+        <p:spPr>
+          <a:xfrm>
+            <a:off x="777240" y="2286000"/>
+            <a:ext cx="10789920" cy="3383280"/>
+          </a:xfrm>
+          <a:prstGeom prst="rect">
+            <a:avLst/>
+          </a:prstGeom>
+          <a:noFill/>
+        </p:spPr>
+        <p:txBody>
+          <a:bodyPr wrap="square">
+            <a:spAutoFit/>
+          </a:bodyPr>
+          <a:lstStyle/>
+          <a:p>
+            <a:pPr>
+              <a:spcAft>
+                <a:spcPts val="1600"/>
+              </a:spcAft>
+              <a:defRPr sz="2400" b="0">
+                <a:solidFill>
+                  <a:srgbClr val="193431"/>
+                </a:solidFill>
+                <a:latin typeface="Arial"/>
+              </a:defRPr>
+            </a:pPr>
+            <a:r>
+              <a:t>• Hoàn thành quy trình dữ liệu → mô hình → ứng dụng</a:t>
+            </a:r>
+          </a:p>
+          <a:p>
+            <a:pPr>
+              <a:spcAft>
+                <a:spcPts val="1600"/>
+              </a:spcAft>
+              <a:defRPr sz="2400" b="0">
+                <a:solidFill>
+                  <a:srgbClr val="193431"/>
+                </a:solidFill>
+                <a:latin typeface="Arial"/>
+              </a:defRPr>
+            </a:pPr>
+            <a:r>
+              <a:t>• Chưa kiểm chứng trên bộ pin xe thực tế tại Việt Nam</a:t>
+            </a:r>
+          </a:p>
+          <a:p>
+            <a:pPr>
+              <a:spcAft>
+                <a:spcPts val="1600"/>
+              </a:spcAft>
+              <a:defRPr sz="2400" b="0">
+                <a:solidFill>
+                  <a:srgbClr val="193431"/>
+                </a:solidFill>
+                <a:latin typeface="Arial"/>
+              </a:defRPr>
+            </a:pPr>
+            <a:r>
+              <a:t>• Mở rộng điều kiện vận hành, đánh giá độc lập và độ bất định</a:t>
+            </a:r>
+          </a:p>
+        </p:txBody>
+      </p:sp>
+      <p:sp>
+        <p:nvSpPr>
+          <p:cNvPr id="6" name="TextBox 5"/>
+          <p:cNvSpPr txBox="1"/>
+          <p:nvPr/>
+        </p:nvSpPr>
+        <p:spPr>
+          <a:xfrm>
+            <a:off x="594360" y="6446520"/>
+            <a:ext cx="10058400" cy="228600"/>
+          </a:xfrm>
+          <a:prstGeom prst="rect">
+            <a:avLst/>
+          </a:prstGeom>
+          <a:noFill/>
+        </p:spPr>
+        <p:txBody>
+          <a:bodyPr wrap="square">
+            <a:spAutoFit/>
+          </a:bodyPr>
+          <a:lstStyle/>
+          <a:p>
+            <a:pPr>
+              <a:spcAft>
+                <a:spcPts val="1600"/>
+              </a:spcAft>
+              <a:defRPr sz="1000" b="0">
+                <a:solidFill>
+                  <a:srgbClr val="60766D"/>
+                </a:solidFill>
+                <a:latin typeface="Arial"/>
+              </a:defRPr>
+            </a:pPr>
+            <a:r>
+              <a:t>Nguyễn Văn Duy · MSSV 2311553949 · Khoa Học Dữ Liệu</a:t>
+            </a:r>
+          </a:p>
+        </p:txBody>
+      </p:sp>
+      <p:sp>
+        <p:nvSpPr>
+          <p:cNvPr id="7" name="TextBox 6"/>
+          <p:cNvSpPr txBox="1"/>
+          <p:nvPr/>
+        </p:nvSpPr>
+        <p:spPr>
+          <a:xfrm>
+            <a:off x="10972800" y="6400800"/>
+            <a:ext cx="548640" cy="274320"/>
+          </a:xfrm>
+          <a:prstGeom prst="rect">
+            <a:avLst/>
+          </a:prstGeom>
+          <a:noFill/>
+        </p:spPr>
+        <p:txBody>
+          <a:bodyPr wrap="square">
+            <a:spAutoFit/>
+          </a:bodyPr>
+          <a:lstStyle/>
+          <a:p>
+            <a:pPr>
+              <a:spcAft>
+                <a:spcPts val="1600"/>
+              </a:spcAft>
+              <a:defRPr sz="1200" b="0">
+                <a:solidFill>
+                  <a:srgbClr val="087F70"/>
+                </a:solidFill>
+                <a:latin typeface="Arial"/>
+              </a:defRPr>
+            </a:pPr>
+            <a:r>
+              <a:t>19</a:t>
             </a:r>
           </a:p>
         </p:txBody>
@@ -6183,6 +6513,302 @@
             </a:pPr>
             <a:r>
               <a:t>02</a:t>
+            </a:r>
+          </a:p>
+        </p:txBody>
+      </p:sp>
+    </p:spTree>
+  </p:cSld>
+  <p:clrMapOvr>
+    <a:masterClrMapping/>
+  </p:clrMapOvr>
+</p:sld>
+</file>
+
+<file path=ppt/slides/slide20.xml><?xml version="1.0" encoding="utf-8"?>
+<p:sld xmlns:a="http://schemas.openxmlformats.org/drawingml/2006/main" xmlns:p="http://schemas.openxmlformats.org/presentationml/2006/main" xmlns:r="http://schemas.openxmlformats.org/officeDocument/2006/relationships">
+  <p:cSld>
+    <p:bg>
+      <p:bgPr>
+        <a:solidFill>
+          <a:srgbClr val="F6F8F3"/>
+        </a:solidFill>
+        <a:effectLst/>
+      </p:bgPr>
+    </p:bg>
+    <p:spTree>
+      <p:nvGrpSpPr>
+        <p:cNvPr id="1" name=""/>
+        <p:cNvGrpSpPr/>
+        <p:nvPr/>
+      </p:nvGrpSpPr>
+      <p:grpSpPr/>
+      <p:sp>
+        <p:nvSpPr>
+          <p:cNvPr id="2" name="Rectangle 1"/>
+          <p:cNvSpPr/>
+          <p:nvPr/>
+        </p:nvSpPr>
+        <p:spPr>
+          <a:xfrm>
+            <a:off x="0" y="0"/>
+            <a:ext cx="146304" cy="6858000"/>
+          </a:xfrm>
+          <a:prstGeom prst="rect">
+            <a:avLst/>
+          </a:prstGeom>
+          <a:solidFill>
+            <a:srgbClr val="087F70"/>
+          </a:solidFill>
+          <a:ln>
+            <a:noFill/>
+          </a:ln>
+        </p:spPr>
+        <p:style>
+          <a:lnRef idx="1">
+            <a:schemeClr val="accent1"/>
+          </a:lnRef>
+          <a:fillRef idx="3">
+            <a:schemeClr val="accent1"/>
+          </a:fillRef>
+          <a:effectRef idx="2">
+            <a:schemeClr val="accent1"/>
+          </a:effectRef>
+          <a:fontRef idx="minor">
+            <a:schemeClr val="lt1"/>
+          </a:fontRef>
+        </p:style>
+        <p:txBody>
+          <a:bodyPr rtlCol="0" anchor="ctr"/>
+          <a:lstStyle/>
+          <a:p>
+            <a:pPr algn="ctr"/>
+          </a:p>
+        </p:txBody>
+      </p:sp>
+      <p:sp>
+        <p:nvSpPr>
+          <p:cNvPr id="3" name="TextBox 2"/>
+          <p:cNvSpPr txBox="1"/>
+          <p:nvPr/>
+        </p:nvSpPr>
+        <p:spPr>
+          <a:xfrm>
+            <a:off x="594360" y="274320"/>
+            <a:ext cx="10972800" cy="365760"/>
+          </a:xfrm>
+          <a:prstGeom prst="rect">
+            <a:avLst/>
+          </a:prstGeom>
+          <a:noFill/>
+        </p:spPr>
+        <p:txBody>
+          <a:bodyPr wrap="square">
+            <a:spAutoFit/>
+          </a:bodyPr>
+          <a:lstStyle/>
+          <a:p>
+            <a:pPr>
+              <a:spcAft>
+                <a:spcPts val="1600"/>
+              </a:spcAft>
+              <a:defRPr sz="1200" b="1">
+                <a:solidFill>
+                  <a:srgbClr val="087F70"/>
+                </a:solidFill>
+                <a:latin typeface="Arial"/>
+              </a:defRPr>
+            </a:pPr>
+            <a:r>
+              <a:t>VINCENT D / NGHIÊN CỨU SỨC KHỎE PIN</a:t>
+            </a:r>
+          </a:p>
+        </p:txBody>
+      </p:sp>
+      <p:sp>
+        <p:nvSpPr>
+          <p:cNvPr id="4" name="TextBox 3"/>
+          <p:cNvSpPr txBox="1"/>
+          <p:nvPr/>
+        </p:nvSpPr>
+        <p:spPr>
+          <a:xfrm>
+            <a:off x="594360" y="868680"/>
+            <a:ext cx="10972800" cy="1188720"/>
+          </a:xfrm>
+          <a:prstGeom prst="rect">
+            <a:avLst/>
+          </a:prstGeom>
+          <a:noFill/>
+        </p:spPr>
+        <p:txBody>
+          <a:bodyPr wrap="square">
+            <a:spAutoFit/>
+          </a:bodyPr>
+          <a:lstStyle/>
+          <a:p>
+            <a:pPr>
+              <a:spcAft>
+                <a:spcPts val="1600"/>
+              </a:spcAft>
+              <a:defRPr sz="3200" b="1">
+                <a:solidFill>
+                  <a:srgbClr val="193431"/>
+                </a:solidFill>
+                <a:latin typeface="Arial"/>
+              </a:defRPr>
+            </a:pPr>
+            <a:r>
+              <a:t>Tài liệu và sản phẩm bàn giao</a:t>
+            </a:r>
+          </a:p>
+        </p:txBody>
+      </p:sp>
+      <p:sp>
+        <p:nvSpPr>
+          <p:cNvPr id="5" name="TextBox 4"/>
+          <p:cNvSpPr txBox="1"/>
+          <p:nvPr/>
+        </p:nvSpPr>
+        <p:spPr>
+          <a:xfrm>
+            <a:off x="777240" y="2286000"/>
+            <a:ext cx="10789920" cy="3383280"/>
+          </a:xfrm>
+          <a:prstGeom prst="rect">
+            <a:avLst/>
+          </a:prstGeom>
+          <a:noFill/>
+        </p:spPr>
+        <p:txBody>
+          <a:bodyPr wrap="square">
+            <a:spAutoFit/>
+          </a:bodyPr>
+          <a:lstStyle/>
+          <a:p>
+            <a:pPr>
+              <a:spcAft>
+                <a:spcPts val="1600"/>
+              </a:spcAft>
+              <a:defRPr sz="2400" b="0">
+                <a:solidFill>
+                  <a:srgbClr val="193431"/>
+                </a:solidFill>
+                <a:latin typeface="Arial"/>
+              </a:defRPr>
+            </a:pPr>
+            <a:r>
+              <a:t>• Mã nguồn, mô hình, bảng đặc trưng và dữ liệu nguồn</a:t>
+            </a:r>
+          </a:p>
+          <a:p>
+            <a:pPr>
+              <a:spcAft>
+                <a:spcPts val="1600"/>
+              </a:spcAft>
+              <a:defRPr sz="2400" b="0">
+                <a:solidFill>
+                  <a:srgbClr val="193431"/>
+                </a:solidFill>
+                <a:latin typeface="Arial"/>
+              </a:defRPr>
+            </a:pPr>
+            <a:r>
+              <a:t>• Notebook đã chạy, CSV thực nghiệm và biểu đồ</a:t>
+            </a:r>
+          </a:p>
+          <a:p>
+            <a:pPr>
+              <a:spcAft>
+                <a:spcPts val="1600"/>
+              </a:spcAft>
+              <a:defRPr sz="2400" b="0">
+                <a:solidFill>
+                  <a:srgbClr val="193431"/>
+                </a:solidFill>
+                <a:latin typeface="Arial"/>
+              </a:defRPr>
+            </a:pPr>
+            <a:r>
+              <a:t>• Báo cáo Word/PDF, slide và hồ sơ trích dẫn</a:t>
+            </a:r>
+          </a:p>
+        </p:txBody>
+      </p:sp>
+      <p:sp>
+        <p:nvSpPr>
+          <p:cNvPr id="6" name="TextBox 5"/>
+          <p:cNvSpPr txBox="1"/>
+          <p:nvPr/>
+        </p:nvSpPr>
+        <p:spPr>
+          <a:xfrm>
+            <a:off x="594360" y="6446520"/>
+            <a:ext cx="10058400" cy="228600"/>
+          </a:xfrm>
+          <a:prstGeom prst="rect">
+            <a:avLst/>
+          </a:prstGeom>
+          <a:noFill/>
+        </p:spPr>
+        <p:txBody>
+          <a:bodyPr wrap="square">
+            <a:spAutoFit/>
+          </a:bodyPr>
+          <a:lstStyle/>
+          <a:p>
+            <a:pPr>
+              <a:spcAft>
+                <a:spcPts val="1600"/>
+              </a:spcAft>
+              <a:defRPr sz="1000" b="0">
+                <a:solidFill>
+                  <a:srgbClr val="60766D"/>
+                </a:solidFill>
+                <a:latin typeface="Arial"/>
+              </a:defRPr>
+            </a:pPr>
+            <a:r>
+              <a:t>Nguyễn Văn Duy · MSSV 2311553949 · Khoa Học Dữ Liệu</a:t>
+            </a:r>
+          </a:p>
+        </p:txBody>
+      </p:sp>
+      <p:sp>
+        <p:nvSpPr>
+          <p:cNvPr id="7" name="TextBox 6"/>
+          <p:cNvSpPr txBox="1"/>
+          <p:nvPr/>
+        </p:nvSpPr>
+        <p:spPr>
+          <a:xfrm>
+            <a:off x="10972800" y="6400800"/>
+            <a:ext cx="548640" cy="274320"/>
+          </a:xfrm>
+          <a:prstGeom prst="rect">
+            <a:avLst/>
+          </a:prstGeom>
+          <a:noFill/>
+        </p:spPr>
+        <p:txBody>
+          <a:bodyPr wrap="square">
+            <a:spAutoFit/>
+          </a:bodyPr>
+          <a:lstStyle/>
+          <a:p>
+            <a:pPr>
+              <a:spcAft>
+                <a:spcPts val="1600"/>
+              </a:spcAft>
+              <a:defRPr sz="1200" b="0">
+                <a:solidFill>
+                  <a:srgbClr val="087F70"/>
+                </a:solidFill>
+                <a:latin typeface="Arial"/>
+              </a:defRPr>
+            </a:pPr>
+            <a:r>
+              <a:t>20</a:t>
             </a:r>
           </a:p>
         </p:txBody>

</xml_diff>

<commit_message>
Vincent D: phương án Ridge–RF phần dư, giám sát xu hướng và demo kiểm thử
</commit_message>
<xml_diff>
--- a/docs/slide-bao-ve.pptx
+++ b/docs/slide-bao-ve.pptx
@@ -23,6 +23,8 @@
     <p:sldId id="271" r:id="rId22"/>
     <p:sldId id="272" r:id="rId23"/>
     <p:sldId id="273" r:id="rId24"/>
+    <p:sldId id="274" r:id="rId25"/>
+    <p:sldId id="275" r:id="rId26"/>
   </p:sldIdLst>
   <p:sldSz cx="12191695" cy="6858000" type="screen4x3"/>
   <p:notesSz cx="6858000" cy="9144000"/>
@@ -5441,7 +5443,7 @@
               </a:defRPr>
             </a:pPr>
             <a:r>
-              <a:t>Kết luận và hướng phát triển</a:t>
+              <a:t>Giám sát xu hướng SOH</a:t>
             </a:r>
           </a:p>
         </p:txBody>
@@ -5480,7 +5482,7 @@
               </a:defRPr>
             </a:pPr>
             <a:r>
-              <a:t>• Hoàn thành quy trình dữ liệu → mô hình → ứng dụng</a:t>
+              <a:t>• Quy tắc quá khứ và Isolation Forest · giữ riêng pin</a:t>
             </a:r>
           </a:p>
           <a:p>
@@ -5496,7 +5498,7 @@
               </a:defRPr>
             </a:pPr>
             <a:r>
-              <a:t>• Chưa kiểm chứng trên bộ pin xe thực tế tại Việt Nam</a:t>
+              <a:t>• 74 cờ giai đoạn đầu; 135 cờ tái sử dụng</a:t>
             </a:r>
           </a:p>
           <a:p>
@@ -5512,7 +5514,23 @@
               </a:defRPr>
             </a:pPr>
             <a:r>
-              <a:t>• Mở rộng điều kiện vận hành, đánh giá độc lập và độ bất định</a:t>
+              <a:t>• Chưa có nhãn lỗi; cờ không phải kết luận hỏng pin</a:t>
+            </a:r>
+          </a:p>
+          <a:p>
+            <a:pPr>
+              <a:spcAft>
+                <a:spcPts val="1600"/>
+              </a:spcAft>
+              <a:defRPr sz="2400" b="0">
+                <a:solidFill>
+                  <a:srgbClr val="193431"/>
+                </a:solidFill>
+                <a:latin typeface="Arial"/>
+              </a:defRPr>
+            </a:pPr>
+            <a:r>
+              <a:t>• Chưa có dữ liệu BMS để kiểm chứng trên xe</a:t>
             </a:r>
           </a:p>
         </p:txBody>
@@ -5737,7 +5755,7 @@
               </a:defRPr>
             </a:pPr>
             <a:r>
-              <a:t>Tài liệu và sản phẩm bàn giao</a:t>
+              <a:t>Ridge–RF hiệu chỉnh phần dư</a:t>
             </a:r>
           </a:p>
         </p:txBody>
@@ -5776,7 +5794,7 @@
               </a:defRPr>
             </a:pPr>
             <a:r>
-              <a:t>• Mã nguồn, mô hình, bảng đặc trưng và dữ liệu nguồn</a:t>
+              <a:t>• Ridge học nền; RF học sai số trên train</a:t>
             </a:r>
           </a:p>
           <a:p>
@@ -5792,7 +5810,7 @@
               </a:defRPr>
             </a:pPr>
             <a:r>
-              <a:t>• Notebook đã chạy, CSV thực nghiệm và biểu đồ</a:t>
+              <a:t>• Cùng 12 đặc trưng và 5 nhóm pin</a:t>
             </a:r>
           </a:p>
           <a:p>
@@ -5808,7 +5826,23 @@
               </a:defRPr>
             </a:pPr>
             <a:r>
-              <a:t>• Báo cáo Word/PDF, slide và hồ sơ trích dẫn</a:t>
+              <a:t>• MAE 1,612 so với RF 1,619; RMSE hơi tăng</a:t>
+            </a:r>
+          </a:p>
+          <a:p>
+            <a:pPr>
+              <a:spcAft>
+                <a:spcPts val="1600"/>
+              </a:spcAft>
+              <a:defRPr sz="2400" b="0">
+                <a:solidFill>
+                  <a:srgbClr val="193431"/>
+                </a:solidFill>
+                <a:latin typeface="Arial"/>
+              </a:defRPr>
+            </a:pPr>
+            <a:r>
+              <a:t>• Kết hợp có sẵn, chưa khẳng định thuật toán mới hay vượt trội</a:t>
             </a:r>
           </a:p>
         </p:txBody>
@@ -5887,6 +5921,302 @@
             </a:pPr>
             <a:r>
               <a:t>18</a:t>
+            </a:r>
+          </a:p>
+        </p:txBody>
+      </p:sp>
+    </p:spTree>
+  </p:cSld>
+  <p:clrMapOvr>
+    <a:masterClrMapping/>
+  </p:clrMapOvr>
+</p:sld>
+</file>
+
+<file path=ppt/slides/slide19.xml><?xml version="1.0" encoding="utf-8"?>
+<p:sld xmlns:a="http://schemas.openxmlformats.org/drawingml/2006/main" xmlns:p="http://schemas.openxmlformats.org/presentationml/2006/main" xmlns:r="http://schemas.openxmlformats.org/officeDocument/2006/relationships">
+  <p:cSld>
+    <p:bg>
+      <p:bgPr>
+        <a:solidFill>
+          <a:srgbClr val="F6F8F3"/>
+        </a:solidFill>
+        <a:effectLst/>
+      </p:bgPr>
+    </p:bg>
+    <p:spTree>
+      <p:nvGrpSpPr>
+        <p:cNvPr id="1" name=""/>
+        <p:cNvGrpSpPr/>
+        <p:nvPr/>
+      </p:nvGrpSpPr>
+      <p:grpSpPr/>
+      <p:sp>
+        <p:nvSpPr>
+          <p:cNvPr id="2" name="Rectangle 1"/>
+          <p:cNvSpPr/>
+          <p:nvPr/>
+        </p:nvSpPr>
+        <p:spPr>
+          <a:xfrm>
+            <a:off x="0" y="0"/>
+            <a:ext cx="146304" cy="6858000"/>
+          </a:xfrm>
+          <a:prstGeom prst="rect">
+            <a:avLst/>
+          </a:prstGeom>
+          <a:solidFill>
+            <a:srgbClr val="087F70"/>
+          </a:solidFill>
+          <a:ln>
+            <a:noFill/>
+          </a:ln>
+        </p:spPr>
+        <p:style>
+          <a:lnRef idx="1">
+            <a:schemeClr val="accent1"/>
+          </a:lnRef>
+          <a:fillRef idx="3">
+            <a:schemeClr val="accent1"/>
+          </a:fillRef>
+          <a:effectRef idx="2">
+            <a:schemeClr val="accent1"/>
+          </a:effectRef>
+          <a:fontRef idx="minor">
+            <a:schemeClr val="lt1"/>
+          </a:fontRef>
+        </p:style>
+        <p:txBody>
+          <a:bodyPr rtlCol="0" anchor="ctr"/>
+          <a:lstStyle/>
+          <a:p>
+            <a:pPr algn="ctr"/>
+          </a:p>
+        </p:txBody>
+      </p:sp>
+      <p:sp>
+        <p:nvSpPr>
+          <p:cNvPr id="3" name="TextBox 2"/>
+          <p:cNvSpPr txBox="1"/>
+          <p:nvPr/>
+        </p:nvSpPr>
+        <p:spPr>
+          <a:xfrm>
+            <a:off x="594360" y="274320"/>
+            <a:ext cx="10972800" cy="365760"/>
+          </a:xfrm>
+          <a:prstGeom prst="rect">
+            <a:avLst/>
+          </a:prstGeom>
+          <a:noFill/>
+        </p:spPr>
+        <p:txBody>
+          <a:bodyPr wrap="square">
+            <a:spAutoFit/>
+          </a:bodyPr>
+          <a:lstStyle/>
+          <a:p>
+            <a:pPr>
+              <a:spcAft>
+                <a:spcPts val="1600"/>
+              </a:spcAft>
+              <a:defRPr sz="1200" b="1">
+                <a:solidFill>
+                  <a:srgbClr val="087F70"/>
+                </a:solidFill>
+                <a:latin typeface="Arial"/>
+              </a:defRPr>
+            </a:pPr>
+            <a:r>
+              <a:t>VINCENT D / NGHIÊN CỨU SỨC KHỎE PIN</a:t>
+            </a:r>
+          </a:p>
+        </p:txBody>
+      </p:sp>
+      <p:sp>
+        <p:nvSpPr>
+          <p:cNvPr id="4" name="TextBox 3"/>
+          <p:cNvSpPr txBox="1"/>
+          <p:nvPr/>
+        </p:nvSpPr>
+        <p:spPr>
+          <a:xfrm>
+            <a:off x="594360" y="868680"/>
+            <a:ext cx="10972800" cy="1188720"/>
+          </a:xfrm>
+          <a:prstGeom prst="rect">
+            <a:avLst/>
+          </a:prstGeom>
+          <a:noFill/>
+        </p:spPr>
+        <p:txBody>
+          <a:bodyPr wrap="square">
+            <a:spAutoFit/>
+          </a:bodyPr>
+          <a:lstStyle/>
+          <a:p>
+            <a:pPr>
+              <a:spcAft>
+                <a:spcPts val="1600"/>
+              </a:spcAft>
+              <a:defRPr sz="3200" b="1">
+                <a:solidFill>
+                  <a:srgbClr val="193431"/>
+                </a:solidFill>
+                <a:latin typeface="Arial"/>
+              </a:defRPr>
+            </a:pPr>
+            <a:r>
+              <a:t>Kết luận và hướng phát triển</a:t>
+            </a:r>
+          </a:p>
+        </p:txBody>
+      </p:sp>
+      <p:sp>
+        <p:nvSpPr>
+          <p:cNvPr id="5" name="TextBox 4"/>
+          <p:cNvSpPr txBox="1"/>
+          <p:nvPr/>
+        </p:nvSpPr>
+        <p:spPr>
+          <a:xfrm>
+            <a:off x="777240" y="2286000"/>
+            <a:ext cx="10789920" cy="3383280"/>
+          </a:xfrm>
+          <a:prstGeom prst="rect">
+            <a:avLst/>
+          </a:prstGeom>
+          <a:noFill/>
+        </p:spPr>
+        <p:txBody>
+          <a:bodyPr wrap="square">
+            <a:spAutoFit/>
+          </a:bodyPr>
+          <a:lstStyle/>
+          <a:p>
+            <a:pPr>
+              <a:spcAft>
+                <a:spcPts val="1600"/>
+              </a:spcAft>
+              <a:defRPr sz="2400" b="0">
+                <a:solidFill>
+                  <a:srgbClr val="193431"/>
+                </a:solidFill>
+                <a:latin typeface="Arial"/>
+              </a:defRPr>
+            </a:pPr>
+            <a:r>
+              <a:t>• Hoàn thành quy trình dữ liệu → mô hình → ứng dụng</a:t>
+            </a:r>
+          </a:p>
+          <a:p>
+            <a:pPr>
+              <a:spcAft>
+                <a:spcPts val="1600"/>
+              </a:spcAft>
+              <a:defRPr sz="2400" b="0">
+                <a:solidFill>
+                  <a:srgbClr val="193431"/>
+                </a:solidFill>
+                <a:latin typeface="Arial"/>
+              </a:defRPr>
+            </a:pPr>
+            <a:r>
+              <a:t>• Chưa kiểm chứng trên bộ pin xe thực tế tại Việt Nam</a:t>
+            </a:r>
+          </a:p>
+          <a:p>
+            <a:pPr>
+              <a:spcAft>
+                <a:spcPts val="1600"/>
+              </a:spcAft>
+              <a:defRPr sz="2400" b="0">
+                <a:solidFill>
+                  <a:srgbClr val="193431"/>
+                </a:solidFill>
+                <a:latin typeface="Arial"/>
+              </a:defRPr>
+            </a:pPr>
+            <a:r>
+              <a:t>• Mở rộng điều kiện vận hành, đánh giá độc lập và độ bất định</a:t>
+            </a:r>
+          </a:p>
+        </p:txBody>
+      </p:sp>
+      <p:sp>
+        <p:nvSpPr>
+          <p:cNvPr id="6" name="TextBox 5"/>
+          <p:cNvSpPr txBox="1"/>
+          <p:nvPr/>
+        </p:nvSpPr>
+        <p:spPr>
+          <a:xfrm>
+            <a:off x="594360" y="6446520"/>
+            <a:ext cx="10058400" cy="228600"/>
+          </a:xfrm>
+          <a:prstGeom prst="rect">
+            <a:avLst/>
+          </a:prstGeom>
+          <a:noFill/>
+        </p:spPr>
+        <p:txBody>
+          <a:bodyPr wrap="square">
+            <a:spAutoFit/>
+          </a:bodyPr>
+          <a:lstStyle/>
+          <a:p>
+            <a:pPr>
+              <a:spcAft>
+                <a:spcPts val="1600"/>
+              </a:spcAft>
+              <a:defRPr sz="1000" b="0">
+                <a:solidFill>
+                  <a:srgbClr val="60766D"/>
+                </a:solidFill>
+                <a:latin typeface="Arial"/>
+              </a:defRPr>
+            </a:pPr>
+            <a:r>
+              <a:t>Nguyễn Văn Duy · MSSV 2311553949 · Khoa Học Dữ Liệu</a:t>
+            </a:r>
+          </a:p>
+        </p:txBody>
+      </p:sp>
+      <p:sp>
+        <p:nvSpPr>
+          <p:cNvPr id="7" name="TextBox 6"/>
+          <p:cNvSpPr txBox="1"/>
+          <p:nvPr/>
+        </p:nvSpPr>
+        <p:spPr>
+          <a:xfrm>
+            <a:off x="10972800" y="6400800"/>
+            <a:ext cx="548640" cy="274320"/>
+          </a:xfrm>
+          <a:prstGeom prst="rect">
+            <a:avLst/>
+          </a:prstGeom>
+          <a:noFill/>
+        </p:spPr>
+        <p:txBody>
+          <a:bodyPr wrap="square">
+            <a:spAutoFit/>
+          </a:bodyPr>
+          <a:lstStyle/>
+          <a:p>
+            <a:pPr>
+              <a:spcAft>
+                <a:spcPts val="1600"/>
+              </a:spcAft>
+              <a:defRPr sz="1200" b="0">
+                <a:solidFill>
+                  <a:srgbClr val="087F70"/>
+                </a:solidFill>
+                <a:latin typeface="Arial"/>
+              </a:defRPr>
+            </a:pPr>
+            <a:r>
+              <a:t>19</a:t>
             </a:r>
           </a:p>
         </p:txBody>
@@ -6183,6 +6513,302 @@
             </a:pPr>
             <a:r>
               <a:t>02</a:t>
+            </a:r>
+          </a:p>
+        </p:txBody>
+      </p:sp>
+    </p:spTree>
+  </p:cSld>
+  <p:clrMapOvr>
+    <a:masterClrMapping/>
+  </p:clrMapOvr>
+</p:sld>
+</file>
+
+<file path=ppt/slides/slide20.xml><?xml version="1.0" encoding="utf-8"?>
+<p:sld xmlns:a="http://schemas.openxmlformats.org/drawingml/2006/main" xmlns:p="http://schemas.openxmlformats.org/presentationml/2006/main" xmlns:r="http://schemas.openxmlformats.org/officeDocument/2006/relationships">
+  <p:cSld>
+    <p:bg>
+      <p:bgPr>
+        <a:solidFill>
+          <a:srgbClr val="F6F8F3"/>
+        </a:solidFill>
+        <a:effectLst/>
+      </p:bgPr>
+    </p:bg>
+    <p:spTree>
+      <p:nvGrpSpPr>
+        <p:cNvPr id="1" name=""/>
+        <p:cNvGrpSpPr/>
+        <p:nvPr/>
+      </p:nvGrpSpPr>
+      <p:grpSpPr/>
+      <p:sp>
+        <p:nvSpPr>
+          <p:cNvPr id="2" name="Rectangle 1"/>
+          <p:cNvSpPr/>
+          <p:nvPr/>
+        </p:nvSpPr>
+        <p:spPr>
+          <a:xfrm>
+            <a:off x="0" y="0"/>
+            <a:ext cx="146304" cy="6858000"/>
+          </a:xfrm>
+          <a:prstGeom prst="rect">
+            <a:avLst/>
+          </a:prstGeom>
+          <a:solidFill>
+            <a:srgbClr val="087F70"/>
+          </a:solidFill>
+          <a:ln>
+            <a:noFill/>
+          </a:ln>
+        </p:spPr>
+        <p:style>
+          <a:lnRef idx="1">
+            <a:schemeClr val="accent1"/>
+          </a:lnRef>
+          <a:fillRef idx="3">
+            <a:schemeClr val="accent1"/>
+          </a:fillRef>
+          <a:effectRef idx="2">
+            <a:schemeClr val="accent1"/>
+          </a:effectRef>
+          <a:fontRef idx="minor">
+            <a:schemeClr val="lt1"/>
+          </a:fontRef>
+        </p:style>
+        <p:txBody>
+          <a:bodyPr rtlCol="0" anchor="ctr"/>
+          <a:lstStyle/>
+          <a:p>
+            <a:pPr algn="ctr"/>
+          </a:p>
+        </p:txBody>
+      </p:sp>
+      <p:sp>
+        <p:nvSpPr>
+          <p:cNvPr id="3" name="TextBox 2"/>
+          <p:cNvSpPr txBox="1"/>
+          <p:nvPr/>
+        </p:nvSpPr>
+        <p:spPr>
+          <a:xfrm>
+            <a:off x="594360" y="274320"/>
+            <a:ext cx="10972800" cy="365760"/>
+          </a:xfrm>
+          <a:prstGeom prst="rect">
+            <a:avLst/>
+          </a:prstGeom>
+          <a:noFill/>
+        </p:spPr>
+        <p:txBody>
+          <a:bodyPr wrap="square">
+            <a:spAutoFit/>
+          </a:bodyPr>
+          <a:lstStyle/>
+          <a:p>
+            <a:pPr>
+              <a:spcAft>
+                <a:spcPts val="1600"/>
+              </a:spcAft>
+              <a:defRPr sz="1200" b="1">
+                <a:solidFill>
+                  <a:srgbClr val="087F70"/>
+                </a:solidFill>
+                <a:latin typeface="Arial"/>
+              </a:defRPr>
+            </a:pPr>
+            <a:r>
+              <a:t>VINCENT D / NGHIÊN CỨU SỨC KHỎE PIN</a:t>
+            </a:r>
+          </a:p>
+        </p:txBody>
+      </p:sp>
+      <p:sp>
+        <p:nvSpPr>
+          <p:cNvPr id="4" name="TextBox 3"/>
+          <p:cNvSpPr txBox="1"/>
+          <p:nvPr/>
+        </p:nvSpPr>
+        <p:spPr>
+          <a:xfrm>
+            <a:off x="594360" y="868680"/>
+            <a:ext cx="10972800" cy="1188720"/>
+          </a:xfrm>
+          <a:prstGeom prst="rect">
+            <a:avLst/>
+          </a:prstGeom>
+          <a:noFill/>
+        </p:spPr>
+        <p:txBody>
+          <a:bodyPr wrap="square">
+            <a:spAutoFit/>
+          </a:bodyPr>
+          <a:lstStyle/>
+          <a:p>
+            <a:pPr>
+              <a:spcAft>
+                <a:spcPts val="1600"/>
+              </a:spcAft>
+              <a:defRPr sz="3200" b="1">
+                <a:solidFill>
+                  <a:srgbClr val="193431"/>
+                </a:solidFill>
+                <a:latin typeface="Arial"/>
+              </a:defRPr>
+            </a:pPr>
+            <a:r>
+              <a:t>Tài liệu và sản phẩm bàn giao</a:t>
+            </a:r>
+          </a:p>
+        </p:txBody>
+      </p:sp>
+      <p:sp>
+        <p:nvSpPr>
+          <p:cNvPr id="5" name="TextBox 4"/>
+          <p:cNvSpPr txBox="1"/>
+          <p:nvPr/>
+        </p:nvSpPr>
+        <p:spPr>
+          <a:xfrm>
+            <a:off x="777240" y="2286000"/>
+            <a:ext cx="10789920" cy="3383280"/>
+          </a:xfrm>
+          <a:prstGeom prst="rect">
+            <a:avLst/>
+          </a:prstGeom>
+          <a:noFill/>
+        </p:spPr>
+        <p:txBody>
+          <a:bodyPr wrap="square">
+            <a:spAutoFit/>
+          </a:bodyPr>
+          <a:lstStyle/>
+          <a:p>
+            <a:pPr>
+              <a:spcAft>
+                <a:spcPts val="1600"/>
+              </a:spcAft>
+              <a:defRPr sz="2400" b="0">
+                <a:solidFill>
+                  <a:srgbClr val="193431"/>
+                </a:solidFill>
+                <a:latin typeface="Arial"/>
+              </a:defRPr>
+            </a:pPr>
+            <a:r>
+              <a:t>• Mã nguồn, mô hình, bảng đặc trưng và dữ liệu nguồn</a:t>
+            </a:r>
+          </a:p>
+          <a:p>
+            <a:pPr>
+              <a:spcAft>
+                <a:spcPts val="1600"/>
+              </a:spcAft>
+              <a:defRPr sz="2400" b="0">
+                <a:solidFill>
+                  <a:srgbClr val="193431"/>
+                </a:solidFill>
+                <a:latin typeface="Arial"/>
+              </a:defRPr>
+            </a:pPr>
+            <a:r>
+              <a:t>• Notebook đã chạy, CSV thực nghiệm và biểu đồ</a:t>
+            </a:r>
+          </a:p>
+          <a:p>
+            <a:pPr>
+              <a:spcAft>
+                <a:spcPts val="1600"/>
+              </a:spcAft>
+              <a:defRPr sz="2400" b="0">
+                <a:solidFill>
+                  <a:srgbClr val="193431"/>
+                </a:solidFill>
+                <a:latin typeface="Arial"/>
+              </a:defRPr>
+            </a:pPr>
+            <a:r>
+              <a:t>• Báo cáo Word/PDF, slide và hồ sơ trích dẫn</a:t>
+            </a:r>
+          </a:p>
+        </p:txBody>
+      </p:sp>
+      <p:sp>
+        <p:nvSpPr>
+          <p:cNvPr id="6" name="TextBox 5"/>
+          <p:cNvSpPr txBox="1"/>
+          <p:nvPr/>
+        </p:nvSpPr>
+        <p:spPr>
+          <a:xfrm>
+            <a:off x="594360" y="6446520"/>
+            <a:ext cx="10058400" cy="228600"/>
+          </a:xfrm>
+          <a:prstGeom prst="rect">
+            <a:avLst/>
+          </a:prstGeom>
+          <a:noFill/>
+        </p:spPr>
+        <p:txBody>
+          <a:bodyPr wrap="square">
+            <a:spAutoFit/>
+          </a:bodyPr>
+          <a:lstStyle/>
+          <a:p>
+            <a:pPr>
+              <a:spcAft>
+                <a:spcPts val="1600"/>
+              </a:spcAft>
+              <a:defRPr sz="1000" b="0">
+                <a:solidFill>
+                  <a:srgbClr val="60766D"/>
+                </a:solidFill>
+                <a:latin typeface="Arial"/>
+              </a:defRPr>
+            </a:pPr>
+            <a:r>
+              <a:t>Nguyễn Văn Duy · MSSV 2311553949 · Khoa Học Dữ Liệu</a:t>
+            </a:r>
+          </a:p>
+        </p:txBody>
+      </p:sp>
+      <p:sp>
+        <p:nvSpPr>
+          <p:cNvPr id="7" name="TextBox 6"/>
+          <p:cNvSpPr txBox="1"/>
+          <p:nvPr/>
+        </p:nvSpPr>
+        <p:spPr>
+          <a:xfrm>
+            <a:off x="10972800" y="6400800"/>
+            <a:ext cx="548640" cy="274320"/>
+          </a:xfrm>
+          <a:prstGeom prst="rect">
+            <a:avLst/>
+          </a:prstGeom>
+          <a:noFill/>
+        </p:spPr>
+        <p:txBody>
+          <a:bodyPr wrap="square">
+            <a:spAutoFit/>
+          </a:bodyPr>
+          <a:lstStyle/>
+          <a:p>
+            <a:pPr>
+              <a:spcAft>
+                <a:spcPts val="1600"/>
+              </a:spcAft>
+              <a:defRPr sz="1200" b="0">
+                <a:solidFill>
+                  <a:srgbClr val="087F70"/>
+                </a:solidFill>
+                <a:latin typeface="Arial"/>
+              </a:defRPr>
+            </a:pPr>
+            <a:r>
+              <a:t>20</a:t>
             </a:r>
           </a:p>
         </p:txBody>

</xml_diff>

<commit_message>
Dự đoán SOH XJTU và báo cáo tiến độ giữa kỳ 10/11
</commit_message>
<xml_diff>
--- a/docs/slide-bao-ve.pptx
+++ b/docs/slide-bao-ve.pptx
@@ -25,6 +25,7 @@
     <p:sldId id="273" r:id="rId24"/>
     <p:sldId id="274" r:id="rId25"/>
     <p:sldId id="275" r:id="rId26"/>
+    <p:sldId id="276" r:id="rId27"/>
   </p:sldIdLst>
   <p:sldSz cx="12191695" cy="6858000" type="screen4x3"/>
   <p:notesSz cx="6858000" cy="9144000"/>
@@ -6067,7 +6068,7 @@
               </a:defRPr>
             </a:pPr>
             <a:r>
-              <a:t>Kết luận và hướng phát triển</a:t>
+              <a:t>Thực nghiệm nguồn XJTU độc lập</a:t>
             </a:r>
           </a:p>
         </p:txBody>
@@ -6106,7 +6107,7 @@
               </a:defRPr>
             </a:pPr>
             <a:r>
-              <a:t>• Hoàn thành quy trình dữ liệu → mô hình → ứng dụng</a:t>
+              <a:t>• 23 pin Lishen NCM 2 Ah; Batch-1/2, giữ riêng pin</a:t>
             </a:r>
           </a:p>
           <a:p>
@@ -6122,7 +6123,7 @@
               </a:defRPr>
             </a:pPr>
             <a:r>
-              <a:t>• Chưa kiểm chứng trên bộ pin xe thực tế tại Việt Nam</a:t>
+              <a:t>• RF: MAE 0.577; RMSE 0.764; R² 0.965</a:t>
             </a:r>
           </a:p>
           <a:p>
@@ -6138,7 +6139,23 @@
               </a:defRPr>
             </a:pPr>
             <a:r>
-              <a:t>• Mở rộng điều kiện vận hành, đánh giá độc lập và độ bất định</a:t>
+              <a:t>• So sánh RF đa nguồn và chuyển miền SDU → XJTU</a:t>
+            </a:r>
+          </a:p>
+          <a:p>
+            <a:pPr>
+              <a:spcAft>
+                <a:spcPts val="1600"/>
+              </a:spcAft>
+              <a:defRPr sz="2400" b="0">
+                <a:solidFill>
+                  <a:srgbClr val="193431"/>
+                </a:solidFill>
+                <a:latin typeface="Arial"/>
+              </a:defRPr>
+            </a:pPr>
+            <a:r>
+              <a:t>• Dữ liệu phòng lab; chưa kiểm chứng BMS trên xe</a:t>
             </a:r>
           </a:p>
         </p:txBody>
@@ -6659,7 +6676,7 @@
               </a:defRPr>
             </a:pPr>
             <a:r>
-              <a:t>Tài liệu và sản phẩm bàn giao</a:t>
+              <a:t>Kết luận và hướng phát triển</a:t>
             </a:r>
           </a:p>
         </p:txBody>
@@ -6698,7 +6715,7 @@
               </a:defRPr>
             </a:pPr>
             <a:r>
-              <a:t>• Mã nguồn, mô hình, bảng đặc trưng và dữ liệu nguồn</a:t>
+              <a:t>• Hoàn thành quy trình dữ liệu → mô hình → ứng dụng</a:t>
             </a:r>
           </a:p>
           <a:p>
@@ -6714,7 +6731,7 @@
               </a:defRPr>
             </a:pPr>
             <a:r>
-              <a:t>• Notebook đã chạy, CSV thực nghiệm và biểu đồ</a:t>
+              <a:t>• Chưa kiểm chứng trên bộ pin xe thực tế tại Việt Nam</a:t>
             </a:r>
           </a:p>
           <a:p>
@@ -6730,7 +6747,7 @@
               </a:defRPr>
             </a:pPr>
             <a:r>
-              <a:t>• Báo cáo Word/PDF, slide và hồ sơ trích dẫn</a:t>
+              <a:t>• Mở rộng điều kiện vận hành, đánh giá độc lập và độ bất định</a:t>
             </a:r>
           </a:p>
         </p:txBody>
@@ -6809,6 +6826,302 @@
             </a:pPr>
             <a:r>
               <a:t>20</a:t>
+            </a:r>
+          </a:p>
+        </p:txBody>
+      </p:sp>
+    </p:spTree>
+  </p:cSld>
+  <p:clrMapOvr>
+    <a:masterClrMapping/>
+  </p:clrMapOvr>
+</p:sld>
+</file>
+
+<file path=ppt/slides/slide21.xml><?xml version="1.0" encoding="utf-8"?>
+<p:sld xmlns:a="http://schemas.openxmlformats.org/drawingml/2006/main" xmlns:p="http://schemas.openxmlformats.org/presentationml/2006/main" xmlns:r="http://schemas.openxmlformats.org/officeDocument/2006/relationships">
+  <p:cSld>
+    <p:bg>
+      <p:bgPr>
+        <a:solidFill>
+          <a:srgbClr val="F6F8F3"/>
+        </a:solidFill>
+        <a:effectLst/>
+      </p:bgPr>
+    </p:bg>
+    <p:spTree>
+      <p:nvGrpSpPr>
+        <p:cNvPr id="1" name=""/>
+        <p:cNvGrpSpPr/>
+        <p:nvPr/>
+      </p:nvGrpSpPr>
+      <p:grpSpPr/>
+      <p:sp>
+        <p:nvSpPr>
+          <p:cNvPr id="2" name="Rectangle 1"/>
+          <p:cNvSpPr/>
+          <p:nvPr/>
+        </p:nvSpPr>
+        <p:spPr>
+          <a:xfrm>
+            <a:off x="0" y="0"/>
+            <a:ext cx="146304" cy="6858000"/>
+          </a:xfrm>
+          <a:prstGeom prst="rect">
+            <a:avLst/>
+          </a:prstGeom>
+          <a:solidFill>
+            <a:srgbClr val="087F70"/>
+          </a:solidFill>
+          <a:ln>
+            <a:noFill/>
+          </a:ln>
+        </p:spPr>
+        <p:style>
+          <a:lnRef idx="1">
+            <a:schemeClr val="accent1"/>
+          </a:lnRef>
+          <a:fillRef idx="3">
+            <a:schemeClr val="accent1"/>
+          </a:fillRef>
+          <a:effectRef idx="2">
+            <a:schemeClr val="accent1"/>
+          </a:effectRef>
+          <a:fontRef idx="minor">
+            <a:schemeClr val="lt1"/>
+          </a:fontRef>
+        </p:style>
+        <p:txBody>
+          <a:bodyPr rtlCol="0" anchor="ctr"/>
+          <a:lstStyle/>
+          <a:p>
+            <a:pPr algn="ctr"/>
+          </a:p>
+        </p:txBody>
+      </p:sp>
+      <p:sp>
+        <p:nvSpPr>
+          <p:cNvPr id="3" name="TextBox 2"/>
+          <p:cNvSpPr txBox="1"/>
+          <p:nvPr/>
+        </p:nvSpPr>
+        <p:spPr>
+          <a:xfrm>
+            <a:off x="594360" y="274320"/>
+            <a:ext cx="10972800" cy="365760"/>
+          </a:xfrm>
+          <a:prstGeom prst="rect">
+            <a:avLst/>
+          </a:prstGeom>
+          <a:noFill/>
+        </p:spPr>
+        <p:txBody>
+          <a:bodyPr wrap="square">
+            <a:spAutoFit/>
+          </a:bodyPr>
+          <a:lstStyle/>
+          <a:p>
+            <a:pPr>
+              <a:spcAft>
+                <a:spcPts val="1600"/>
+              </a:spcAft>
+              <a:defRPr sz="1200" b="1">
+                <a:solidFill>
+                  <a:srgbClr val="087F70"/>
+                </a:solidFill>
+                <a:latin typeface="Arial"/>
+              </a:defRPr>
+            </a:pPr>
+            <a:r>
+              <a:t>VINCENT D / NGHIÊN CỨU SỨC KHỎE PIN</a:t>
+            </a:r>
+          </a:p>
+        </p:txBody>
+      </p:sp>
+      <p:sp>
+        <p:nvSpPr>
+          <p:cNvPr id="4" name="TextBox 3"/>
+          <p:cNvSpPr txBox="1"/>
+          <p:nvPr/>
+        </p:nvSpPr>
+        <p:spPr>
+          <a:xfrm>
+            <a:off x="594360" y="868680"/>
+            <a:ext cx="10972800" cy="1188720"/>
+          </a:xfrm>
+          <a:prstGeom prst="rect">
+            <a:avLst/>
+          </a:prstGeom>
+          <a:noFill/>
+        </p:spPr>
+        <p:txBody>
+          <a:bodyPr wrap="square">
+            <a:spAutoFit/>
+          </a:bodyPr>
+          <a:lstStyle/>
+          <a:p>
+            <a:pPr>
+              <a:spcAft>
+                <a:spcPts val="1600"/>
+              </a:spcAft>
+              <a:defRPr sz="3200" b="1">
+                <a:solidFill>
+                  <a:srgbClr val="193431"/>
+                </a:solidFill>
+                <a:latin typeface="Arial"/>
+              </a:defRPr>
+            </a:pPr>
+            <a:r>
+              <a:t>Tài liệu và sản phẩm bàn giao</a:t>
+            </a:r>
+          </a:p>
+        </p:txBody>
+      </p:sp>
+      <p:sp>
+        <p:nvSpPr>
+          <p:cNvPr id="5" name="TextBox 4"/>
+          <p:cNvSpPr txBox="1"/>
+          <p:nvPr/>
+        </p:nvSpPr>
+        <p:spPr>
+          <a:xfrm>
+            <a:off x="777240" y="2286000"/>
+            <a:ext cx="10789920" cy="3383280"/>
+          </a:xfrm>
+          <a:prstGeom prst="rect">
+            <a:avLst/>
+          </a:prstGeom>
+          <a:noFill/>
+        </p:spPr>
+        <p:txBody>
+          <a:bodyPr wrap="square">
+            <a:spAutoFit/>
+          </a:bodyPr>
+          <a:lstStyle/>
+          <a:p>
+            <a:pPr>
+              <a:spcAft>
+                <a:spcPts val="1600"/>
+              </a:spcAft>
+              <a:defRPr sz="2400" b="0">
+                <a:solidFill>
+                  <a:srgbClr val="193431"/>
+                </a:solidFill>
+                <a:latin typeface="Arial"/>
+              </a:defRPr>
+            </a:pPr>
+            <a:r>
+              <a:t>• Mã nguồn, mô hình, bảng đặc trưng và dữ liệu nguồn</a:t>
+            </a:r>
+          </a:p>
+          <a:p>
+            <a:pPr>
+              <a:spcAft>
+                <a:spcPts val="1600"/>
+              </a:spcAft>
+              <a:defRPr sz="2400" b="0">
+                <a:solidFill>
+                  <a:srgbClr val="193431"/>
+                </a:solidFill>
+                <a:latin typeface="Arial"/>
+              </a:defRPr>
+            </a:pPr>
+            <a:r>
+              <a:t>• Notebook đã chạy, CSV thực nghiệm và biểu đồ</a:t>
+            </a:r>
+          </a:p>
+          <a:p>
+            <a:pPr>
+              <a:spcAft>
+                <a:spcPts val="1600"/>
+              </a:spcAft>
+              <a:defRPr sz="2400" b="0">
+                <a:solidFill>
+                  <a:srgbClr val="193431"/>
+                </a:solidFill>
+                <a:latin typeface="Arial"/>
+              </a:defRPr>
+            </a:pPr>
+            <a:r>
+              <a:t>• Báo cáo Word/PDF, slide và hồ sơ trích dẫn</a:t>
+            </a:r>
+          </a:p>
+        </p:txBody>
+      </p:sp>
+      <p:sp>
+        <p:nvSpPr>
+          <p:cNvPr id="6" name="TextBox 5"/>
+          <p:cNvSpPr txBox="1"/>
+          <p:nvPr/>
+        </p:nvSpPr>
+        <p:spPr>
+          <a:xfrm>
+            <a:off x="594360" y="6446520"/>
+            <a:ext cx="10058400" cy="228600"/>
+          </a:xfrm>
+          <a:prstGeom prst="rect">
+            <a:avLst/>
+          </a:prstGeom>
+          <a:noFill/>
+        </p:spPr>
+        <p:txBody>
+          <a:bodyPr wrap="square">
+            <a:spAutoFit/>
+          </a:bodyPr>
+          <a:lstStyle/>
+          <a:p>
+            <a:pPr>
+              <a:spcAft>
+                <a:spcPts val="1600"/>
+              </a:spcAft>
+              <a:defRPr sz="1000" b="0">
+                <a:solidFill>
+                  <a:srgbClr val="60766D"/>
+                </a:solidFill>
+                <a:latin typeface="Arial"/>
+              </a:defRPr>
+            </a:pPr>
+            <a:r>
+              <a:t>Nguyễn Văn Duy · MSSV 2311553949 · Khoa Học Dữ Liệu</a:t>
+            </a:r>
+          </a:p>
+        </p:txBody>
+      </p:sp>
+      <p:sp>
+        <p:nvSpPr>
+          <p:cNvPr id="7" name="TextBox 6"/>
+          <p:cNvSpPr txBox="1"/>
+          <p:nvPr/>
+        </p:nvSpPr>
+        <p:spPr>
+          <a:xfrm>
+            <a:off x="10972800" y="6400800"/>
+            <a:ext cx="548640" cy="274320"/>
+          </a:xfrm>
+          <a:prstGeom prst="rect">
+            <a:avLst/>
+          </a:prstGeom>
+          <a:noFill/>
+        </p:spPr>
+        <p:txBody>
+          <a:bodyPr wrap="square">
+            <a:spAutoFit/>
+          </a:bodyPr>
+          <a:lstStyle/>
+          <a:p>
+            <a:pPr>
+              <a:spcAft>
+                <a:spcPts val="1600"/>
+              </a:spcAft>
+              <a:defRPr sz="1200" b="0">
+                <a:solidFill>
+                  <a:srgbClr val="087F70"/>
+                </a:solidFill>
+                <a:latin typeface="Arial"/>
+              </a:defRPr>
+            </a:pPr>
+            <a:r>
+              <a:t>21</a:t>
             </a:r>
           </a:p>
         </p:txBody>

</xml_diff>

<commit_message>
Sản phẩm SDU và XJTU, kết quả kiểm thử và hồ sơ giữa kỳ 10/11
</commit_message>
<xml_diff>
--- a/docs/slide-bao-ve.pptx
+++ b/docs/slide-bao-ve.pptx
@@ -25,6 +25,7 @@
     <p:sldId id="273" r:id="rId24"/>
     <p:sldId id="274" r:id="rId25"/>
     <p:sldId id="275" r:id="rId26"/>
+    <p:sldId id="276" r:id="rId27"/>
   </p:sldIdLst>
   <p:sldSz cx="12191695" cy="6858000" type="screen4x3"/>
   <p:notesSz cx="6858000" cy="9144000"/>
@@ -6067,7 +6068,7 @@
               </a:defRPr>
             </a:pPr>
             <a:r>
-              <a:t>Kết luận và hướng phát triển</a:t>
+              <a:t>Thực nghiệm nguồn XJTU độc lập</a:t>
             </a:r>
           </a:p>
         </p:txBody>
@@ -6106,7 +6107,7 @@
               </a:defRPr>
             </a:pPr>
             <a:r>
-              <a:t>• Hoàn thành quy trình dữ liệu → mô hình → ứng dụng</a:t>
+              <a:t>• 23 pin Lishen NCM 2 Ah; Batch-1/2, giữ riêng pin</a:t>
             </a:r>
           </a:p>
           <a:p>
@@ -6122,7 +6123,7 @@
               </a:defRPr>
             </a:pPr>
             <a:r>
-              <a:t>• Chưa kiểm chứng trên bộ pin xe thực tế tại Việt Nam</a:t>
+              <a:t>• RF: MAE 0.577; RMSE 0.764; R² 0.965</a:t>
             </a:r>
           </a:p>
           <a:p>
@@ -6138,7 +6139,23 @@
               </a:defRPr>
             </a:pPr>
             <a:r>
-              <a:t>• Mở rộng điều kiện vận hành, đánh giá độc lập và độ bất định</a:t>
+              <a:t>• So sánh RF đa nguồn và chuyển miền SDU → XJTU</a:t>
+            </a:r>
+          </a:p>
+          <a:p>
+            <a:pPr>
+              <a:spcAft>
+                <a:spcPts val="1600"/>
+              </a:spcAft>
+              <a:defRPr sz="2400" b="0">
+                <a:solidFill>
+                  <a:srgbClr val="193431"/>
+                </a:solidFill>
+                <a:latin typeface="Arial"/>
+              </a:defRPr>
+            </a:pPr>
+            <a:r>
+              <a:t>• Dữ liệu phòng lab; chưa kiểm chứng BMS trên xe</a:t>
             </a:r>
           </a:p>
         </p:txBody>
@@ -6659,7 +6676,7 @@
               </a:defRPr>
             </a:pPr>
             <a:r>
-              <a:t>Tài liệu và sản phẩm bàn giao</a:t>
+              <a:t>Kết luận và hướng phát triển</a:t>
             </a:r>
           </a:p>
         </p:txBody>
@@ -6698,7 +6715,7 @@
               </a:defRPr>
             </a:pPr>
             <a:r>
-              <a:t>• Mã nguồn, mô hình, bảng đặc trưng và dữ liệu nguồn</a:t>
+              <a:t>• Hoàn thành quy trình dữ liệu → mô hình → ứng dụng</a:t>
             </a:r>
           </a:p>
           <a:p>
@@ -6714,7 +6731,7 @@
               </a:defRPr>
             </a:pPr>
             <a:r>
-              <a:t>• Notebook đã chạy, CSV thực nghiệm và biểu đồ</a:t>
+              <a:t>• Chưa kiểm chứng trên bộ pin xe thực tế tại Việt Nam</a:t>
             </a:r>
           </a:p>
           <a:p>
@@ -6730,7 +6747,7 @@
               </a:defRPr>
             </a:pPr>
             <a:r>
-              <a:t>• Báo cáo Word/PDF, slide và hồ sơ trích dẫn</a:t>
+              <a:t>• Mở rộng điều kiện vận hành, đánh giá độc lập và độ bất định</a:t>
             </a:r>
           </a:p>
         </p:txBody>
@@ -6809,6 +6826,302 @@
             </a:pPr>
             <a:r>
               <a:t>20</a:t>
+            </a:r>
+          </a:p>
+        </p:txBody>
+      </p:sp>
+    </p:spTree>
+  </p:cSld>
+  <p:clrMapOvr>
+    <a:masterClrMapping/>
+  </p:clrMapOvr>
+</p:sld>
+</file>
+
+<file path=ppt/slides/slide21.xml><?xml version="1.0" encoding="utf-8"?>
+<p:sld xmlns:a="http://schemas.openxmlformats.org/drawingml/2006/main" xmlns:p="http://schemas.openxmlformats.org/presentationml/2006/main" xmlns:r="http://schemas.openxmlformats.org/officeDocument/2006/relationships">
+  <p:cSld>
+    <p:bg>
+      <p:bgPr>
+        <a:solidFill>
+          <a:srgbClr val="F6F8F3"/>
+        </a:solidFill>
+        <a:effectLst/>
+      </p:bgPr>
+    </p:bg>
+    <p:spTree>
+      <p:nvGrpSpPr>
+        <p:cNvPr id="1" name=""/>
+        <p:cNvGrpSpPr/>
+        <p:nvPr/>
+      </p:nvGrpSpPr>
+      <p:grpSpPr/>
+      <p:sp>
+        <p:nvSpPr>
+          <p:cNvPr id="2" name="Rectangle 1"/>
+          <p:cNvSpPr/>
+          <p:nvPr/>
+        </p:nvSpPr>
+        <p:spPr>
+          <a:xfrm>
+            <a:off x="0" y="0"/>
+            <a:ext cx="146304" cy="6858000"/>
+          </a:xfrm>
+          <a:prstGeom prst="rect">
+            <a:avLst/>
+          </a:prstGeom>
+          <a:solidFill>
+            <a:srgbClr val="087F70"/>
+          </a:solidFill>
+          <a:ln>
+            <a:noFill/>
+          </a:ln>
+        </p:spPr>
+        <p:style>
+          <a:lnRef idx="1">
+            <a:schemeClr val="accent1"/>
+          </a:lnRef>
+          <a:fillRef idx="3">
+            <a:schemeClr val="accent1"/>
+          </a:fillRef>
+          <a:effectRef idx="2">
+            <a:schemeClr val="accent1"/>
+          </a:effectRef>
+          <a:fontRef idx="minor">
+            <a:schemeClr val="lt1"/>
+          </a:fontRef>
+        </p:style>
+        <p:txBody>
+          <a:bodyPr rtlCol="0" anchor="ctr"/>
+          <a:lstStyle/>
+          <a:p>
+            <a:pPr algn="ctr"/>
+          </a:p>
+        </p:txBody>
+      </p:sp>
+      <p:sp>
+        <p:nvSpPr>
+          <p:cNvPr id="3" name="TextBox 2"/>
+          <p:cNvSpPr txBox="1"/>
+          <p:nvPr/>
+        </p:nvSpPr>
+        <p:spPr>
+          <a:xfrm>
+            <a:off x="594360" y="274320"/>
+            <a:ext cx="10972800" cy="365760"/>
+          </a:xfrm>
+          <a:prstGeom prst="rect">
+            <a:avLst/>
+          </a:prstGeom>
+          <a:noFill/>
+        </p:spPr>
+        <p:txBody>
+          <a:bodyPr wrap="square">
+            <a:spAutoFit/>
+          </a:bodyPr>
+          <a:lstStyle/>
+          <a:p>
+            <a:pPr>
+              <a:spcAft>
+                <a:spcPts val="1600"/>
+              </a:spcAft>
+              <a:defRPr sz="1200" b="1">
+                <a:solidFill>
+                  <a:srgbClr val="087F70"/>
+                </a:solidFill>
+                <a:latin typeface="Arial"/>
+              </a:defRPr>
+            </a:pPr>
+            <a:r>
+              <a:t>VINCENT D / NGHIÊN CỨU SỨC KHỎE PIN</a:t>
+            </a:r>
+          </a:p>
+        </p:txBody>
+      </p:sp>
+      <p:sp>
+        <p:nvSpPr>
+          <p:cNvPr id="4" name="TextBox 3"/>
+          <p:cNvSpPr txBox="1"/>
+          <p:nvPr/>
+        </p:nvSpPr>
+        <p:spPr>
+          <a:xfrm>
+            <a:off x="594360" y="868680"/>
+            <a:ext cx="10972800" cy="1188720"/>
+          </a:xfrm>
+          <a:prstGeom prst="rect">
+            <a:avLst/>
+          </a:prstGeom>
+          <a:noFill/>
+        </p:spPr>
+        <p:txBody>
+          <a:bodyPr wrap="square">
+            <a:spAutoFit/>
+          </a:bodyPr>
+          <a:lstStyle/>
+          <a:p>
+            <a:pPr>
+              <a:spcAft>
+                <a:spcPts val="1600"/>
+              </a:spcAft>
+              <a:defRPr sz="3200" b="1">
+                <a:solidFill>
+                  <a:srgbClr val="193431"/>
+                </a:solidFill>
+                <a:latin typeface="Arial"/>
+              </a:defRPr>
+            </a:pPr>
+            <a:r>
+              <a:t>Tài liệu và sản phẩm bàn giao</a:t>
+            </a:r>
+          </a:p>
+        </p:txBody>
+      </p:sp>
+      <p:sp>
+        <p:nvSpPr>
+          <p:cNvPr id="5" name="TextBox 4"/>
+          <p:cNvSpPr txBox="1"/>
+          <p:nvPr/>
+        </p:nvSpPr>
+        <p:spPr>
+          <a:xfrm>
+            <a:off x="777240" y="2286000"/>
+            <a:ext cx="10789920" cy="3383280"/>
+          </a:xfrm>
+          <a:prstGeom prst="rect">
+            <a:avLst/>
+          </a:prstGeom>
+          <a:noFill/>
+        </p:spPr>
+        <p:txBody>
+          <a:bodyPr wrap="square">
+            <a:spAutoFit/>
+          </a:bodyPr>
+          <a:lstStyle/>
+          <a:p>
+            <a:pPr>
+              <a:spcAft>
+                <a:spcPts val="1600"/>
+              </a:spcAft>
+              <a:defRPr sz="2400" b="0">
+                <a:solidFill>
+                  <a:srgbClr val="193431"/>
+                </a:solidFill>
+                <a:latin typeface="Arial"/>
+              </a:defRPr>
+            </a:pPr>
+            <a:r>
+              <a:t>• Mã nguồn, mô hình, bảng đặc trưng và dữ liệu nguồn</a:t>
+            </a:r>
+          </a:p>
+          <a:p>
+            <a:pPr>
+              <a:spcAft>
+                <a:spcPts val="1600"/>
+              </a:spcAft>
+              <a:defRPr sz="2400" b="0">
+                <a:solidFill>
+                  <a:srgbClr val="193431"/>
+                </a:solidFill>
+                <a:latin typeface="Arial"/>
+              </a:defRPr>
+            </a:pPr>
+            <a:r>
+              <a:t>• Notebook đã chạy, CSV thực nghiệm và biểu đồ</a:t>
+            </a:r>
+          </a:p>
+          <a:p>
+            <a:pPr>
+              <a:spcAft>
+                <a:spcPts val="1600"/>
+              </a:spcAft>
+              <a:defRPr sz="2400" b="0">
+                <a:solidFill>
+                  <a:srgbClr val="193431"/>
+                </a:solidFill>
+                <a:latin typeface="Arial"/>
+              </a:defRPr>
+            </a:pPr>
+            <a:r>
+              <a:t>• Báo cáo Word/PDF, slide và hồ sơ trích dẫn</a:t>
+            </a:r>
+          </a:p>
+        </p:txBody>
+      </p:sp>
+      <p:sp>
+        <p:nvSpPr>
+          <p:cNvPr id="6" name="TextBox 5"/>
+          <p:cNvSpPr txBox="1"/>
+          <p:nvPr/>
+        </p:nvSpPr>
+        <p:spPr>
+          <a:xfrm>
+            <a:off x="594360" y="6446520"/>
+            <a:ext cx="10058400" cy="228600"/>
+          </a:xfrm>
+          <a:prstGeom prst="rect">
+            <a:avLst/>
+          </a:prstGeom>
+          <a:noFill/>
+        </p:spPr>
+        <p:txBody>
+          <a:bodyPr wrap="square">
+            <a:spAutoFit/>
+          </a:bodyPr>
+          <a:lstStyle/>
+          <a:p>
+            <a:pPr>
+              <a:spcAft>
+                <a:spcPts val="1600"/>
+              </a:spcAft>
+              <a:defRPr sz="1000" b="0">
+                <a:solidFill>
+                  <a:srgbClr val="60766D"/>
+                </a:solidFill>
+                <a:latin typeface="Arial"/>
+              </a:defRPr>
+            </a:pPr>
+            <a:r>
+              <a:t>Nguyễn Văn Duy · MSSV 2311553949 · Khoa Học Dữ Liệu</a:t>
+            </a:r>
+          </a:p>
+        </p:txBody>
+      </p:sp>
+      <p:sp>
+        <p:nvSpPr>
+          <p:cNvPr id="7" name="TextBox 6"/>
+          <p:cNvSpPr txBox="1"/>
+          <p:nvPr/>
+        </p:nvSpPr>
+        <p:spPr>
+          <a:xfrm>
+            <a:off x="10972800" y="6400800"/>
+            <a:ext cx="548640" cy="274320"/>
+          </a:xfrm>
+          <a:prstGeom prst="rect">
+            <a:avLst/>
+          </a:prstGeom>
+          <a:noFill/>
+        </p:spPr>
+        <p:txBody>
+          <a:bodyPr wrap="square">
+            <a:spAutoFit/>
+          </a:bodyPr>
+          <a:lstStyle/>
+          <a:p>
+            <a:pPr>
+              <a:spcAft>
+                <a:spcPts val="1600"/>
+              </a:spcAft>
+              <a:defRPr sz="1200" b="0">
+                <a:solidFill>
+                  <a:srgbClr val="087F70"/>
+                </a:solidFill>
+                <a:latin typeface="Arial"/>
+              </a:defRPr>
+            </a:pPr>
+            <a:r>
+              <a:t>21</a:t>
             </a:r>
           </a:p>
         </p:txBody>

</xml_diff>